<commit_message>
feat: add video and fix presentation and specification
</commit_message>
<xml_diff>
--- a/2026_Б_ККП_ПЗПІ-23-1_Тітаренко_М_С.pptx
+++ b/2026_Б_ККП_ПЗПІ-23-1_Тітаренко_М_С.pptx
@@ -4,6 +4,9 @@
   <p:sldMasterIdLst>
     <p:sldMasterId id="2147483648" r:id="rId1"/>
   </p:sldMasterIdLst>
+  <p:notesMasterIdLst>
+    <p:notesMasterId r:id="rId14"/>
+  </p:notesMasterIdLst>
   <p:sldIdLst>
     <p:sldId id="256" r:id="rId2"/>
     <p:sldId id="257" r:id="rId3"/>
@@ -115,7 +118,361 @@
       </a:defRPr>
     </a:lvl9pPr>
   </p:defaultTextStyle>
+  <p:extLst>
+    <p:ext uri="{EFAFB233-063F-42B5-8137-9DF3F51BA10A}">
+      <p15:sldGuideLst xmlns:p15="http://schemas.microsoft.com/office/powerpoint/2012/main"/>
+    </p:ext>
+  </p:extLst>
 </p:presentation>
+</file>
+
+<file path=ppt/notesMasters/notesMaster1.xml><?xml version="1.0" encoding="utf-8"?>
+<p:notesMaster xmlns:a="http://schemas.openxmlformats.org/drawingml/2006/main" xmlns:r="http://schemas.openxmlformats.org/officeDocument/2006/relationships" xmlns:p="http://schemas.openxmlformats.org/presentationml/2006/main">
+  <p:cSld>
+    <p:bg>
+      <p:bgRef idx="1001">
+        <a:schemeClr val="bg1"/>
+      </p:bgRef>
+    </p:bg>
+    <p:spTree>
+      <p:nvGrpSpPr>
+        <p:cNvPr id="1" name=""/>
+        <p:cNvGrpSpPr/>
+        <p:nvPr/>
+      </p:nvGrpSpPr>
+      <p:grpSpPr>
+        <a:xfrm>
+          <a:off x="0" y="0"/>
+          <a:ext cx="0" cy="0"/>
+          <a:chOff x="0" y="0"/>
+          <a:chExt cx="0" cy="0"/>
+        </a:xfrm>
+      </p:grpSpPr>
+      <p:sp>
+        <p:nvSpPr>
+          <p:cNvPr id="2" name="Місце для верхнього колонтитула 1"/>
+          <p:cNvSpPr>
+            <a:spLocks noGrp="1"/>
+          </p:cNvSpPr>
+          <p:nvPr>
+            <p:ph type="hdr" sz="quarter"/>
+          </p:nvPr>
+        </p:nvSpPr>
+        <p:spPr>
+          <a:xfrm>
+            <a:off x="0" y="0"/>
+            <a:ext cx="2971800" cy="458788"/>
+          </a:xfrm>
+          <a:prstGeom prst="rect">
+            <a:avLst/>
+          </a:prstGeom>
+        </p:spPr>
+        <p:txBody>
+          <a:bodyPr vert="horz" lIns="91440" tIns="45720" rIns="91440" bIns="45720" rtlCol="0"/>
+          <a:lstStyle>
+            <a:lvl1pPr algn="l">
+              <a:defRPr sz="1200"/>
+            </a:lvl1pPr>
+          </a:lstStyle>
+          <a:p>
+            <a:endParaRPr lang="uk-UA"/>
+          </a:p>
+        </p:txBody>
+      </p:sp>
+      <p:sp>
+        <p:nvSpPr>
+          <p:cNvPr id="3" name="Місце для дати 2"/>
+          <p:cNvSpPr>
+            <a:spLocks noGrp="1"/>
+          </p:cNvSpPr>
+          <p:nvPr>
+            <p:ph type="dt" idx="1"/>
+          </p:nvPr>
+        </p:nvSpPr>
+        <p:spPr>
+          <a:xfrm>
+            <a:off x="3884613" y="0"/>
+            <a:ext cx="2971800" cy="458788"/>
+          </a:xfrm>
+          <a:prstGeom prst="rect">
+            <a:avLst/>
+          </a:prstGeom>
+        </p:spPr>
+        <p:txBody>
+          <a:bodyPr vert="horz" lIns="91440" tIns="45720" rIns="91440" bIns="45720" rtlCol="0"/>
+          <a:lstStyle>
+            <a:lvl1pPr algn="r">
+              <a:defRPr sz="1200"/>
+            </a:lvl1pPr>
+          </a:lstStyle>
+          <a:p>
+            <a:fld id="{7C0E86BE-4F3A-4D9E-B99A-B861765272E0}" type="datetimeFigureOut">
+              <a:rPr lang="uk-UA" smtClean="0"/>
+              <a:t>10.05.2026</a:t>
+            </a:fld>
+            <a:endParaRPr lang="uk-UA"/>
+          </a:p>
+        </p:txBody>
+      </p:sp>
+      <p:sp>
+        <p:nvSpPr>
+          <p:cNvPr id="4" name="Місце для зображення 3"/>
+          <p:cNvSpPr>
+            <a:spLocks noGrp="1" noRot="1" noChangeAspect="1"/>
+          </p:cNvSpPr>
+          <p:nvPr>
+            <p:ph type="sldImg" idx="2"/>
+          </p:nvPr>
+        </p:nvSpPr>
+        <p:spPr>
+          <a:xfrm>
+            <a:off x="685800" y="1143000"/>
+            <a:ext cx="5486400" cy="3086100"/>
+          </a:xfrm>
+          <a:prstGeom prst="rect">
+            <a:avLst/>
+          </a:prstGeom>
+          <a:noFill/>
+          <a:ln w="12700">
+            <a:solidFill>
+              <a:prstClr val="black"/>
+            </a:solidFill>
+          </a:ln>
+        </p:spPr>
+        <p:txBody>
+          <a:bodyPr vert="horz" lIns="91440" tIns="45720" rIns="91440" bIns="45720" rtlCol="0" anchor="ctr"/>
+          <a:lstStyle/>
+          <a:p>
+            <a:endParaRPr lang="uk-UA"/>
+          </a:p>
+        </p:txBody>
+      </p:sp>
+      <p:sp>
+        <p:nvSpPr>
+          <p:cNvPr id="5" name="Місце для нотаток 4"/>
+          <p:cNvSpPr>
+            <a:spLocks noGrp="1"/>
+          </p:cNvSpPr>
+          <p:nvPr>
+            <p:ph type="body" sz="quarter" idx="3"/>
+          </p:nvPr>
+        </p:nvSpPr>
+        <p:spPr>
+          <a:xfrm>
+            <a:off x="685800" y="4400550"/>
+            <a:ext cx="5486400" cy="3600450"/>
+          </a:xfrm>
+          <a:prstGeom prst="rect">
+            <a:avLst/>
+          </a:prstGeom>
+        </p:spPr>
+        <p:txBody>
+          <a:bodyPr vert="horz" lIns="91440" tIns="45720" rIns="91440" bIns="45720" rtlCol="0"/>
+          <a:lstStyle/>
+          <a:p>
+            <a:pPr lvl="0"/>
+            <a:r>
+              <a:rPr lang="uk-UA"/>
+              <a:t>Клацніть, щоб відредагувати стилі зразків тексту</a:t>
+            </a:r>
+          </a:p>
+          <a:p>
+            <a:pPr lvl="1"/>
+            <a:r>
+              <a:rPr lang="uk-UA"/>
+              <a:t>Другий рівень</a:t>
+            </a:r>
+          </a:p>
+          <a:p>
+            <a:pPr lvl="2"/>
+            <a:r>
+              <a:rPr lang="uk-UA"/>
+              <a:t>Третій рівень</a:t>
+            </a:r>
+          </a:p>
+          <a:p>
+            <a:pPr lvl="3"/>
+            <a:r>
+              <a:rPr lang="uk-UA"/>
+              <a:t>Четвертий рівень</a:t>
+            </a:r>
+          </a:p>
+          <a:p>
+            <a:pPr lvl="4"/>
+            <a:r>
+              <a:rPr lang="uk-UA"/>
+              <a:t>П’ятий рівень</a:t>
+            </a:r>
+          </a:p>
+        </p:txBody>
+      </p:sp>
+      <p:sp>
+        <p:nvSpPr>
+          <p:cNvPr id="6" name="Місце для нижнього колонтитула 5"/>
+          <p:cNvSpPr>
+            <a:spLocks noGrp="1"/>
+          </p:cNvSpPr>
+          <p:nvPr>
+            <p:ph type="ftr" sz="quarter" idx="4"/>
+          </p:nvPr>
+        </p:nvSpPr>
+        <p:spPr>
+          <a:xfrm>
+            <a:off x="0" y="8685213"/>
+            <a:ext cx="2971800" cy="458787"/>
+          </a:xfrm>
+          <a:prstGeom prst="rect">
+            <a:avLst/>
+          </a:prstGeom>
+        </p:spPr>
+        <p:txBody>
+          <a:bodyPr vert="horz" lIns="91440" tIns="45720" rIns="91440" bIns="45720" rtlCol="0" anchor="b"/>
+          <a:lstStyle>
+            <a:lvl1pPr algn="l">
+              <a:defRPr sz="1200"/>
+            </a:lvl1pPr>
+          </a:lstStyle>
+          <a:p>
+            <a:endParaRPr lang="uk-UA"/>
+          </a:p>
+        </p:txBody>
+      </p:sp>
+      <p:sp>
+        <p:nvSpPr>
+          <p:cNvPr id="7" name="Місце для номера слайда 6"/>
+          <p:cNvSpPr>
+            <a:spLocks noGrp="1"/>
+          </p:cNvSpPr>
+          <p:nvPr>
+            <p:ph type="sldNum" sz="quarter" idx="5"/>
+          </p:nvPr>
+        </p:nvSpPr>
+        <p:spPr>
+          <a:xfrm>
+            <a:off x="3884613" y="8685213"/>
+            <a:ext cx="2971800" cy="458787"/>
+          </a:xfrm>
+          <a:prstGeom prst="rect">
+            <a:avLst/>
+          </a:prstGeom>
+        </p:spPr>
+        <p:txBody>
+          <a:bodyPr vert="horz" lIns="91440" tIns="45720" rIns="91440" bIns="45720" rtlCol="0" anchor="b"/>
+          <a:lstStyle>
+            <a:lvl1pPr algn="r">
+              <a:defRPr sz="1200"/>
+            </a:lvl1pPr>
+          </a:lstStyle>
+          <a:p>
+            <a:fld id="{727363BB-1934-4E2F-BD7B-378825138779}" type="slidenum">
+              <a:rPr lang="uk-UA" smtClean="0"/>
+              <a:t>‹№›</a:t>
+            </a:fld>
+            <a:endParaRPr lang="uk-UA"/>
+          </a:p>
+        </p:txBody>
+      </p:sp>
+    </p:spTree>
+    <p:extLst>
+      <p:ext uri="{BB962C8B-B14F-4D97-AF65-F5344CB8AC3E}">
+        <p14:creationId xmlns:p14="http://schemas.microsoft.com/office/powerpoint/2010/main" val="3850262605"/>
+      </p:ext>
+    </p:extLst>
+  </p:cSld>
+  <p:clrMap bg1="lt1" tx1="dk1" bg2="lt2" tx2="dk2" accent1="accent1" accent2="accent2" accent3="accent3" accent4="accent4" accent5="accent5" accent6="accent6" hlink="hlink" folHlink="folHlink"/>
+  <p:notesStyle>
+    <a:lvl1pPr marL="0" algn="l" defTabSz="914400" rtl="0" eaLnBrk="1" latinLnBrk="0" hangingPunct="1">
+      <a:defRPr sz="1200" kern="1200">
+        <a:solidFill>
+          <a:schemeClr val="tx1"/>
+        </a:solidFill>
+        <a:latin typeface="+mn-lt"/>
+        <a:ea typeface="+mn-ea"/>
+        <a:cs typeface="+mn-cs"/>
+      </a:defRPr>
+    </a:lvl1pPr>
+    <a:lvl2pPr marL="457200" algn="l" defTabSz="914400" rtl="0" eaLnBrk="1" latinLnBrk="0" hangingPunct="1">
+      <a:defRPr sz="1200" kern="1200">
+        <a:solidFill>
+          <a:schemeClr val="tx1"/>
+        </a:solidFill>
+        <a:latin typeface="+mn-lt"/>
+        <a:ea typeface="+mn-ea"/>
+        <a:cs typeface="+mn-cs"/>
+      </a:defRPr>
+    </a:lvl2pPr>
+    <a:lvl3pPr marL="914400" algn="l" defTabSz="914400" rtl="0" eaLnBrk="1" latinLnBrk="0" hangingPunct="1">
+      <a:defRPr sz="1200" kern="1200">
+        <a:solidFill>
+          <a:schemeClr val="tx1"/>
+        </a:solidFill>
+        <a:latin typeface="+mn-lt"/>
+        <a:ea typeface="+mn-ea"/>
+        <a:cs typeface="+mn-cs"/>
+      </a:defRPr>
+    </a:lvl3pPr>
+    <a:lvl4pPr marL="1371600" algn="l" defTabSz="914400" rtl="0" eaLnBrk="1" latinLnBrk="0" hangingPunct="1">
+      <a:defRPr sz="1200" kern="1200">
+        <a:solidFill>
+          <a:schemeClr val="tx1"/>
+        </a:solidFill>
+        <a:latin typeface="+mn-lt"/>
+        <a:ea typeface="+mn-ea"/>
+        <a:cs typeface="+mn-cs"/>
+      </a:defRPr>
+    </a:lvl4pPr>
+    <a:lvl5pPr marL="1828800" algn="l" defTabSz="914400" rtl="0" eaLnBrk="1" latinLnBrk="0" hangingPunct="1">
+      <a:defRPr sz="1200" kern="1200">
+        <a:solidFill>
+          <a:schemeClr val="tx1"/>
+        </a:solidFill>
+        <a:latin typeface="+mn-lt"/>
+        <a:ea typeface="+mn-ea"/>
+        <a:cs typeface="+mn-cs"/>
+      </a:defRPr>
+    </a:lvl5pPr>
+    <a:lvl6pPr marL="2286000" algn="l" defTabSz="914400" rtl="0" eaLnBrk="1" latinLnBrk="0" hangingPunct="1">
+      <a:defRPr sz="1200" kern="1200">
+        <a:solidFill>
+          <a:schemeClr val="tx1"/>
+        </a:solidFill>
+        <a:latin typeface="+mn-lt"/>
+        <a:ea typeface="+mn-ea"/>
+        <a:cs typeface="+mn-cs"/>
+      </a:defRPr>
+    </a:lvl6pPr>
+    <a:lvl7pPr marL="2743200" algn="l" defTabSz="914400" rtl="0" eaLnBrk="1" latinLnBrk="0" hangingPunct="1">
+      <a:defRPr sz="1200" kern="1200">
+        <a:solidFill>
+          <a:schemeClr val="tx1"/>
+        </a:solidFill>
+        <a:latin typeface="+mn-lt"/>
+        <a:ea typeface="+mn-ea"/>
+        <a:cs typeface="+mn-cs"/>
+      </a:defRPr>
+    </a:lvl7pPr>
+    <a:lvl8pPr marL="3200400" algn="l" defTabSz="914400" rtl="0" eaLnBrk="1" latinLnBrk="0" hangingPunct="1">
+      <a:defRPr sz="1200" kern="1200">
+        <a:solidFill>
+          <a:schemeClr val="tx1"/>
+        </a:solidFill>
+        <a:latin typeface="+mn-lt"/>
+        <a:ea typeface="+mn-ea"/>
+        <a:cs typeface="+mn-cs"/>
+      </a:defRPr>
+    </a:lvl8pPr>
+    <a:lvl9pPr marL="3657600" algn="l" defTabSz="914400" rtl="0" eaLnBrk="1" latinLnBrk="0" hangingPunct="1">
+      <a:defRPr sz="1200" kern="1200">
+        <a:solidFill>
+          <a:schemeClr val="tx1"/>
+        </a:solidFill>
+        <a:latin typeface="+mn-lt"/>
+        <a:ea typeface="+mn-ea"/>
+        <a:cs typeface="+mn-cs"/>
+      </a:defRPr>
+    </a:lvl9pPr>
+  </p:notesStyle>
+</p:notesMaster>
 </file>
 
 <file path=ppt/slideLayouts/slideLayout1.xml><?xml version="1.0" encoding="utf-8"?>
@@ -261,11 +618,20 @@
         <p:spPr/>
         <p:txBody>
           <a:bodyPr/>
-          <a:lstStyle/>
-          <a:p>
-            <a:fld id="{9633DF4F-DE4A-4D52-9CD6-9DC9A5F90436}" type="datetimeFigureOut">
+          <a:lstStyle>
+            <a:lvl1pPr>
+              <a:defRPr sz="2000">
+                <a:solidFill>
+                  <a:schemeClr val="bg1"/>
+                </a:solidFill>
+              </a:defRPr>
+            </a:lvl1pPr>
+          </a:lstStyle>
+          <a:p>
+            <a:fld id="{90348686-127C-4120-B616-4289040A7004}" type="datetime1">
               <a:rPr lang="uk-UA" smtClean="0"/>
-              <a:t>09.05.2026</a:t>
+              <a:pPr/>
+              <a:t>10.05.2026</a:t>
             </a:fld>
             <a:endParaRPr lang="uk-UA"/>
           </a:p>
@@ -290,7 +656,15 @@
         <p:spPr/>
         <p:txBody>
           <a:bodyPr/>
-          <a:lstStyle/>
+          <a:lstStyle>
+            <a:lvl1pPr>
+              <a:defRPr sz="2000">
+                <a:solidFill>
+                  <a:schemeClr val="bg1"/>
+                </a:solidFill>
+              </a:defRPr>
+            </a:lvl1pPr>
+          </a:lstStyle>
           <a:p>
             <a:endParaRPr lang="uk-UA"/>
           </a:p>
@@ -315,10 +689,19 @@
         <p:spPr/>
         <p:txBody>
           <a:bodyPr/>
-          <a:lstStyle/>
+          <a:lstStyle>
+            <a:lvl1pPr>
+              <a:defRPr sz="2000">
+                <a:solidFill>
+                  <a:schemeClr val="bg1"/>
+                </a:solidFill>
+              </a:defRPr>
+            </a:lvl1pPr>
+          </a:lstStyle>
           <a:p>
             <a:fld id="{4381394B-84A4-4EB2-8589-B7B2B99E12DD}" type="slidenum">
               <a:rPr lang="uk-UA" smtClean="0"/>
+              <a:pPr/>
               <a:t>‹№›</a:t>
             </a:fld>
             <a:endParaRPr lang="uk-UA"/>
@@ -461,9 +844,9 @@
           <a:bodyPr/>
           <a:lstStyle/>
           <a:p>
-            <a:fld id="{9633DF4F-DE4A-4D52-9CD6-9DC9A5F90436}" type="datetimeFigureOut">
+            <a:fld id="{8A5E2E62-B2D6-445C-97A7-4E362A639F85}" type="datetime1">
               <a:rPr lang="uk-UA" smtClean="0"/>
-              <a:t>09.05.2026</a:t>
+              <a:t>10.05.2026</a:t>
             </a:fld>
             <a:endParaRPr lang="uk-UA"/>
           </a:p>
@@ -669,9 +1052,9 @@
           <a:bodyPr/>
           <a:lstStyle/>
           <a:p>
-            <a:fld id="{9633DF4F-DE4A-4D52-9CD6-9DC9A5F90436}" type="datetimeFigureOut">
+            <a:fld id="{088131B2-0C14-4D6A-B416-AEFA39167D01}" type="datetime1">
               <a:rPr lang="uk-UA" smtClean="0"/>
-              <a:t>09.05.2026</a:t>
+              <a:t>10.05.2026</a:t>
             </a:fld>
             <a:endParaRPr lang="uk-UA"/>
           </a:p>
@@ -867,9 +1250,9 @@
           <a:bodyPr/>
           <a:lstStyle/>
           <a:p>
-            <a:fld id="{9633DF4F-DE4A-4D52-9CD6-9DC9A5F90436}" type="datetimeFigureOut">
+            <a:fld id="{EAF0E85B-4845-4781-865F-5550AB148711}" type="datetime1">
               <a:rPr lang="uk-UA" smtClean="0"/>
-              <a:t>09.05.2026</a:t>
+              <a:t>10.05.2026</a:t>
             </a:fld>
             <a:endParaRPr lang="uk-UA"/>
           </a:p>
@@ -1142,9 +1525,9 @@
           <a:bodyPr/>
           <a:lstStyle/>
           <a:p>
-            <a:fld id="{9633DF4F-DE4A-4D52-9CD6-9DC9A5F90436}" type="datetimeFigureOut">
+            <a:fld id="{CF79F800-79AF-4D29-8061-B44F112B4F16}" type="datetime1">
               <a:rPr lang="uk-UA" smtClean="0"/>
-              <a:t>09.05.2026</a:t>
+              <a:t>10.05.2026</a:t>
             </a:fld>
             <a:endParaRPr lang="uk-UA"/>
           </a:p>
@@ -1407,9 +1790,9 @@
           <a:bodyPr/>
           <a:lstStyle/>
           <a:p>
-            <a:fld id="{9633DF4F-DE4A-4D52-9CD6-9DC9A5F90436}" type="datetimeFigureOut">
+            <a:fld id="{833F35E6-0E1E-43D0-9122-A10F0C3C76F0}" type="datetime1">
               <a:rPr lang="uk-UA" smtClean="0"/>
-              <a:t>09.05.2026</a:t>
+              <a:t>10.05.2026</a:t>
             </a:fld>
             <a:endParaRPr lang="uk-UA"/>
           </a:p>
@@ -1819,9 +2202,9 @@
           <a:bodyPr/>
           <a:lstStyle/>
           <a:p>
-            <a:fld id="{9633DF4F-DE4A-4D52-9CD6-9DC9A5F90436}" type="datetimeFigureOut">
+            <a:fld id="{2ADC24B8-F4D3-47BA-8462-D930645CC0D3}" type="datetime1">
               <a:rPr lang="uk-UA" smtClean="0"/>
-              <a:t>09.05.2026</a:t>
+              <a:t>10.05.2026</a:t>
             </a:fld>
             <a:endParaRPr lang="uk-UA"/>
           </a:p>
@@ -1960,9 +2343,9 @@
           <a:bodyPr/>
           <a:lstStyle/>
           <a:p>
-            <a:fld id="{9633DF4F-DE4A-4D52-9CD6-9DC9A5F90436}" type="datetimeFigureOut">
+            <a:fld id="{7CF2D6B8-6BD3-4E74-ADB0-D69C04FF6FCE}" type="datetime1">
               <a:rPr lang="uk-UA" smtClean="0"/>
-              <a:t>09.05.2026</a:t>
+              <a:t>10.05.2026</a:t>
             </a:fld>
             <a:endParaRPr lang="uk-UA"/>
           </a:p>
@@ -2073,9 +2456,9 @@
           <a:bodyPr/>
           <a:lstStyle/>
           <a:p>
-            <a:fld id="{9633DF4F-DE4A-4D52-9CD6-9DC9A5F90436}" type="datetimeFigureOut">
+            <a:fld id="{0740A61B-1D10-4C78-B082-8FC64DB93002}" type="datetime1">
               <a:rPr lang="uk-UA" smtClean="0"/>
-              <a:t>09.05.2026</a:t>
+              <a:t>10.05.2026</a:t>
             </a:fld>
             <a:endParaRPr lang="uk-UA"/>
           </a:p>
@@ -2384,9 +2767,9 @@
           <a:bodyPr/>
           <a:lstStyle/>
           <a:p>
-            <a:fld id="{9633DF4F-DE4A-4D52-9CD6-9DC9A5F90436}" type="datetimeFigureOut">
+            <a:fld id="{C8540211-4A3E-4809-B89D-7BC3F90112BC}" type="datetime1">
               <a:rPr lang="uk-UA" smtClean="0"/>
-              <a:t>09.05.2026</a:t>
+              <a:t>10.05.2026</a:t>
             </a:fld>
             <a:endParaRPr lang="uk-UA"/>
           </a:p>
@@ -2672,9 +3055,9 @@
           <a:bodyPr/>
           <a:lstStyle/>
           <a:p>
-            <a:fld id="{9633DF4F-DE4A-4D52-9CD6-9DC9A5F90436}" type="datetimeFigureOut">
+            <a:fld id="{8A697D8A-AA77-4F03-936A-A3FB0932A535}" type="datetime1">
               <a:rPr lang="uk-UA" smtClean="0"/>
-              <a:t>09.05.2026</a:t>
+              <a:t>10.05.2026</a:t>
             </a:fld>
             <a:endParaRPr lang="uk-UA"/>
           </a:p>
@@ -2913,9 +3296,9 @@
             </a:lvl1pPr>
           </a:lstStyle>
           <a:p>
-            <a:fld id="{9633DF4F-DE4A-4D52-9CD6-9DC9A5F90436}" type="datetimeFigureOut">
+            <a:fld id="{925D61AF-8FD6-4C0B-AB26-C005D1C08023}" type="datetime1">
               <a:rPr lang="uk-UA" smtClean="0"/>
-              <a:t>09.05.2026</a:t>
+              <a:t>10.05.2026</a:t>
             </a:fld>
             <a:endParaRPr lang="uk-UA"/>
           </a:p>
@@ -3032,6 +3415,7 @@
     <p:sldLayoutId id="2147483658" r:id="rId10"/>
     <p:sldLayoutId id="2147483659" r:id="rId11"/>
   </p:sldLayoutIdLst>
+  <p:hf hdr="0" ftr="0" dt="0"/>
   <p:txStyles>
     <p:titleStyle>
       <a:lvl1pPr algn="l" defTabSz="914400" rtl="0" eaLnBrk="1" latinLnBrk="0" hangingPunct="1">
@@ -3634,6 +4018,43 @@
           </a:p>
         </p:txBody>
       </p:sp>
+      <p:sp>
+        <p:nvSpPr>
+          <p:cNvPr id="2" name="Місце для номера слайда 1">
+            <a:extLst>
+              <a:ext uri="{FF2B5EF4-FFF2-40B4-BE49-F238E27FC236}">
+                <a16:creationId xmlns:a16="http://schemas.microsoft.com/office/drawing/2014/main" id="{B2B4CCCD-9C68-4F59-8967-6453FA8F566A}"/>
+              </a:ext>
+            </a:extLst>
+          </p:cNvPr>
+          <p:cNvSpPr>
+            <a:spLocks noGrp="1"/>
+          </p:cNvSpPr>
+          <p:nvPr>
+            <p:ph type="sldNum" sz="quarter" idx="12"/>
+          </p:nvPr>
+        </p:nvSpPr>
+        <p:spPr/>
+        <p:txBody>
+          <a:bodyPr/>
+          <a:lstStyle/>
+          <a:p>
+            <a:fld id="{4381394B-84A4-4EB2-8589-B7B2B99E12DD}" type="slidenum">
+              <a:rPr lang="uk-UA" sz="1800" b="1" smtClean="0">
+                <a:solidFill>
+                  <a:schemeClr val="bg1"/>
+                </a:solidFill>
+              </a:rPr>
+              <a:t>1</a:t>
+            </a:fld>
+            <a:endParaRPr lang="uk-UA" sz="1800" b="1" dirty="0">
+              <a:solidFill>
+                <a:schemeClr val="bg1"/>
+              </a:solidFill>
+            </a:endParaRPr>
+          </a:p>
+        </p:txBody>
+      </p:sp>
     </p:spTree>
     <p:extLst>
       <p:ext uri="{BB962C8B-B14F-4D97-AF65-F5344CB8AC3E}">
@@ -3873,6 +4294,35 @@
           </a:p>
         </p:txBody>
       </p:sp>
+      <p:sp>
+        <p:nvSpPr>
+          <p:cNvPr id="3" name="Місце для номера слайда 2">
+            <a:extLst>
+              <a:ext uri="{FF2B5EF4-FFF2-40B4-BE49-F238E27FC236}">
+                <a16:creationId xmlns:a16="http://schemas.microsoft.com/office/drawing/2014/main" id="{4F6E02CB-BB38-4D8F-843D-26CA6360C274}"/>
+              </a:ext>
+            </a:extLst>
+          </p:cNvPr>
+          <p:cNvSpPr>
+            <a:spLocks noGrp="1"/>
+          </p:cNvSpPr>
+          <p:nvPr>
+            <p:ph type="sldNum" sz="quarter" idx="12"/>
+          </p:nvPr>
+        </p:nvSpPr>
+        <p:spPr/>
+        <p:txBody>
+          <a:bodyPr/>
+          <a:lstStyle/>
+          <a:p>
+            <a:fld id="{4381394B-84A4-4EB2-8589-B7B2B99E12DD}" type="slidenum">
+              <a:rPr lang="uk-UA" smtClean="0"/>
+              <a:t>10</a:t>
+            </a:fld>
+            <a:endParaRPr lang="uk-UA"/>
+          </a:p>
+        </p:txBody>
+      </p:sp>
     </p:spTree>
     <p:extLst>
       <p:ext uri="{BB962C8B-B14F-4D97-AF65-F5344CB8AC3E}">
@@ -4120,6 +4570,35 @@
           </a:prstGeom>
         </p:spPr>
       </p:pic>
+      <p:sp>
+        <p:nvSpPr>
+          <p:cNvPr id="3" name="Місце для номера слайда 2">
+            <a:extLst>
+              <a:ext uri="{FF2B5EF4-FFF2-40B4-BE49-F238E27FC236}">
+                <a16:creationId xmlns:a16="http://schemas.microsoft.com/office/drawing/2014/main" id="{50ADF179-34AF-4174-9BC1-34A6A1D8B98B}"/>
+              </a:ext>
+            </a:extLst>
+          </p:cNvPr>
+          <p:cNvSpPr>
+            <a:spLocks noGrp="1"/>
+          </p:cNvSpPr>
+          <p:nvPr>
+            <p:ph type="sldNum" sz="quarter" idx="12"/>
+          </p:nvPr>
+        </p:nvSpPr>
+        <p:spPr/>
+        <p:txBody>
+          <a:bodyPr/>
+          <a:lstStyle/>
+          <a:p>
+            <a:fld id="{4381394B-84A4-4EB2-8589-B7B2B99E12DD}" type="slidenum">
+              <a:rPr lang="uk-UA" smtClean="0"/>
+              <a:t>11</a:t>
+            </a:fld>
+            <a:endParaRPr lang="uk-UA"/>
+          </a:p>
+        </p:txBody>
+      </p:sp>
     </p:spTree>
     <p:extLst>
       <p:ext uri="{BB962C8B-B14F-4D97-AF65-F5344CB8AC3E}">
@@ -4427,6 +4906,35 @@
           </a:p>
         </p:txBody>
       </p:sp>
+      <p:sp>
+        <p:nvSpPr>
+          <p:cNvPr id="2" name="Місце для номера слайда 1">
+            <a:extLst>
+              <a:ext uri="{FF2B5EF4-FFF2-40B4-BE49-F238E27FC236}">
+                <a16:creationId xmlns:a16="http://schemas.microsoft.com/office/drawing/2014/main" id="{8FA9AD34-A568-4003-89D6-93B5C2B27FD6}"/>
+              </a:ext>
+            </a:extLst>
+          </p:cNvPr>
+          <p:cNvSpPr>
+            <a:spLocks noGrp="1"/>
+          </p:cNvSpPr>
+          <p:nvPr>
+            <p:ph type="sldNum" sz="quarter" idx="12"/>
+          </p:nvPr>
+        </p:nvSpPr>
+        <p:spPr/>
+        <p:txBody>
+          <a:bodyPr/>
+          <a:lstStyle/>
+          <a:p>
+            <a:fld id="{4381394B-84A4-4EB2-8589-B7B2B99E12DD}" type="slidenum">
+              <a:rPr lang="uk-UA" smtClean="0"/>
+              <a:t>12</a:t>
+            </a:fld>
+            <a:endParaRPr lang="uk-UA"/>
+          </a:p>
+        </p:txBody>
+      </p:sp>
     </p:spTree>
     <p:extLst>
       <p:ext uri="{BB962C8B-B14F-4D97-AF65-F5344CB8AC3E}">
@@ -4826,6 +5334,35 @@
             <a:endParaRPr lang="uk-UA" dirty="0">
               <a:latin typeface="Arial" panose="020B0604020202020204" pitchFamily="34" charset="0"/>
             </a:endParaRPr>
+          </a:p>
+        </p:txBody>
+      </p:sp>
+      <p:sp>
+        <p:nvSpPr>
+          <p:cNvPr id="2" name="Місце для номера слайда 1">
+            <a:extLst>
+              <a:ext uri="{FF2B5EF4-FFF2-40B4-BE49-F238E27FC236}">
+                <a16:creationId xmlns:a16="http://schemas.microsoft.com/office/drawing/2014/main" id="{FDB498EC-AF43-4992-B366-A762E25B5A3A}"/>
+              </a:ext>
+            </a:extLst>
+          </p:cNvPr>
+          <p:cNvSpPr>
+            <a:spLocks noGrp="1"/>
+          </p:cNvSpPr>
+          <p:nvPr>
+            <p:ph type="sldNum" sz="quarter" idx="12"/>
+          </p:nvPr>
+        </p:nvSpPr>
+        <p:spPr/>
+        <p:txBody>
+          <a:bodyPr/>
+          <a:lstStyle/>
+          <a:p>
+            <a:fld id="{4381394B-84A4-4EB2-8589-B7B2B99E12DD}" type="slidenum">
+              <a:rPr lang="uk-UA" smtClean="0"/>
+              <a:t>2</a:t>
+            </a:fld>
+            <a:endParaRPr lang="uk-UA"/>
           </a:p>
         </p:txBody>
       </p:sp>
@@ -5561,6 +6098,35 @@
           </a:p>
         </p:txBody>
       </p:sp>
+      <p:sp>
+        <p:nvSpPr>
+          <p:cNvPr id="2" name="Місце для номера слайда 1">
+            <a:extLst>
+              <a:ext uri="{FF2B5EF4-FFF2-40B4-BE49-F238E27FC236}">
+                <a16:creationId xmlns:a16="http://schemas.microsoft.com/office/drawing/2014/main" id="{C731EDC0-7D0F-4E83-83F5-713C184A2F52}"/>
+              </a:ext>
+            </a:extLst>
+          </p:cNvPr>
+          <p:cNvSpPr>
+            <a:spLocks noGrp="1"/>
+          </p:cNvSpPr>
+          <p:nvPr>
+            <p:ph type="sldNum" sz="quarter" idx="12"/>
+          </p:nvPr>
+        </p:nvSpPr>
+        <p:spPr/>
+        <p:txBody>
+          <a:bodyPr/>
+          <a:lstStyle/>
+          <a:p>
+            <a:fld id="{4381394B-84A4-4EB2-8589-B7B2B99E12DD}" type="slidenum">
+              <a:rPr lang="uk-UA" smtClean="0"/>
+              <a:t>3</a:t>
+            </a:fld>
+            <a:endParaRPr lang="uk-UA"/>
+          </a:p>
+        </p:txBody>
+      </p:sp>
     </p:spTree>
     <p:extLst>
       <p:ext uri="{BB962C8B-B14F-4D97-AF65-F5344CB8AC3E}">
@@ -6054,6 +6620,35 @@
           </a:p>
         </p:txBody>
       </p:sp>
+      <p:sp>
+        <p:nvSpPr>
+          <p:cNvPr id="2" name="Місце для номера слайда 1">
+            <a:extLst>
+              <a:ext uri="{FF2B5EF4-FFF2-40B4-BE49-F238E27FC236}">
+                <a16:creationId xmlns:a16="http://schemas.microsoft.com/office/drawing/2014/main" id="{EE2C75D1-C87D-40BB-AEAC-6DB79A970A38}"/>
+              </a:ext>
+            </a:extLst>
+          </p:cNvPr>
+          <p:cNvSpPr>
+            <a:spLocks noGrp="1"/>
+          </p:cNvSpPr>
+          <p:nvPr>
+            <p:ph type="sldNum" sz="quarter" idx="12"/>
+          </p:nvPr>
+        </p:nvSpPr>
+        <p:spPr/>
+        <p:txBody>
+          <a:bodyPr/>
+          <a:lstStyle/>
+          <a:p>
+            <a:fld id="{4381394B-84A4-4EB2-8589-B7B2B99E12DD}" type="slidenum">
+              <a:rPr lang="uk-UA" smtClean="0"/>
+              <a:t>4</a:t>
+            </a:fld>
+            <a:endParaRPr lang="uk-UA"/>
+          </a:p>
+        </p:txBody>
+      </p:sp>
     </p:spTree>
     <p:extLst>
       <p:ext uri="{BB962C8B-B14F-4D97-AF65-F5344CB8AC3E}">
@@ -6274,6 +6869,35 @@
           </a:p>
         </p:txBody>
       </p:sp>
+      <p:sp>
+        <p:nvSpPr>
+          <p:cNvPr id="2" name="Місце для номера слайда 1">
+            <a:extLst>
+              <a:ext uri="{FF2B5EF4-FFF2-40B4-BE49-F238E27FC236}">
+                <a16:creationId xmlns:a16="http://schemas.microsoft.com/office/drawing/2014/main" id="{4D4CF0F4-29E1-4073-8CC0-E06C979C4142}"/>
+              </a:ext>
+            </a:extLst>
+          </p:cNvPr>
+          <p:cNvSpPr>
+            <a:spLocks noGrp="1"/>
+          </p:cNvSpPr>
+          <p:nvPr>
+            <p:ph type="sldNum" sz="quarter" idx="12"/>
+          </p:nvPr>
+        </p:nvSpPr>
+        <p:spPr/>
+        <p:txBody>
+          <a:bodyPr/>
+          <a:lstStyle/>
+          <a:p>
+            <a:fld id="{4381394B-84A4-4EB2-8589-B7B2B99E12DD}" type="slidenum">
+              <a:rPr lang="uk-UA" smtClean="0"/>
+              <a:t>5</a:t>
+            </a:fld>
+            <a:endParaRPr lang="uk-UA"/>
+          </a:p>
+        </p:txBody>
+      </p:sp>
     </p:spTree>
     <p:extLst>
       <p:ext uri="{BB962C8B-B14F-4D97-AF65-F5344CB8AC3E}">
@@ -6562,6 +7186,35 @@
           </a:p>
         </p:txBody>
       </p:sp>
+      <p:sp>
+        <p:nvSpPr>
+          <p:cNvPr id="2" name="Місце для номера слайда 1">
+            <a:extLst>
+              <a:ext uri="{FF2B5EF4-FFF2-40B4-BE49-F238E27FC236}">
+                <a16:creationId xmlns:a16="http://schemas.microsoft.com/office/drawing/2014/main" id="{B0A7BAC7-F1A6-4D53-8A67-430523722102}"/>
+              </a:ext>
+            </a:extLst>
+          </p:cNvPr>
+          <p:cNvSpPr>
+            <a:spLocks noGrp="1"/>
+          </p:cNvSpPr>
+          <p:nvPr>
+            <p:ph type="sldNum" sz="quarter" idx="12"/>
+          </p:nvPr>
+        </p:nvSpPr>
+        <p:spPr/>
+        <p:txBody>
+          <a:bodyPr/>
+          <a:lstStyle/>
+          <a:p>
+            <a:fld id="{4381394B-84A4-4EB2-8589-B7B2B99E12DD}" type="slidenum">
+              <a:rPr lang="uk-UA" smtClean="0"/>
+              <a:t>6</a:t>
+            </a:fld>
+            <a:endParaRPr lang="uk-UA"/>
+          </a:p>
+        </p:txBody>
+      </p:sp>
     </p:spTree>
     <p:extLst>
       <p:ext uri="{BB962C8B-B14F-4D97-AF65-F5344CB8AC3E}">
@@ -6643,12 +7296,48 @@
           </a:p>
         </p:txBody>
       </p:sp>
+      <p:sp>
+        <p:nvSpPr>
+          <p:cNvPr id="2" name="Прямокутник 1">
+            <a:extLst>
+              <a:ext uri="{FF2B5EF4-FFF2-40B4-BE49-F238E27FC236}">
+                <a16:creationId xmlns:a16="http://schemas.microsoft.com/office/drawing/2014/main" id="{20414F42-0A7C-4EE5-9D1D-B8A493FD4477}"/>
+              </a:ext>
+            </a:extLst>
+          </p:cNvPr>
+          <p:cNvSpPr/>
+          <p:nvPr/>
+        </p:nvSpPr>
+        <p:spPr>
+          <a:xfrm>
+            <a:off x="1265659" y="1969013"/>
+            <a:ext cx="4275438" cy="646331"/>
+          </a:xfrm>
+          <a:prstGeom prst="rect">
+            <a:avLst/>
+          </a:prstGeom>
+        </p:spPr>
+        <p:txBody>
+          <a:bodyPr wrap="square">
+            <a:spAutoFit/>
+          </a:bodyPr>
+          <a:lstStyle/>
+          <a:p>
+            <a:r>
+              <a:rPr lang="uk-UA" dirty="0">
+                <a:latin typeface="Arial" panose="020B0604020202020204" pitchFamily="34" charset="0"/>
+              </a:rPr>
+              <a:t>UML-діаграма класів для сутностей, які реалізовують процес гри</a:t>
+            </a:r>
+          </a:p>
+        </p:txBody>
+      </p:sp>
       <p:pic>
         <p:nvPicPr>
-          <p:cNvPr id="5" name="Рисунок 4">
-            <a:extLst>
-              <a:ext uri="{FF2B5EF4-FFF2-40B4-BE49-F238E27FC236}">
-                <a16:creationId xmlns:a16="http://schemas.microsoft.com/office/drawing/2014/main" id="{7B13F2DA-C97E-4306-BA09-B98E8E2BCF98}"/>
+          <p:cNvPr id="6" name="Рисунок 5">
+            <a:extLst>
+              <a:ext uri="{FF2B5EF4-FFF2-40B4-BE49-F238E27FC236}">
+                <a16:creationId xmlns:a16="http://schemas.microsoft.com/office/drawing/2014/main" id="{4BC4A56C-5666-448E-B0E5-06E67350B743}"/>
               </a:ext>
             </a:extLst>
           </p:cNvPr>
@@ -6656,7 +7345,7 @@
           <p:nvPr/>
         </p:nvPicPr>
         <p:blipFill>
-          <a:blip r:embed="rId3" cstate="print">
+          <a:blip r:embed="rId3">
             <a:extLst>
               <a:ext uri="{28A0092B-C50C-407E-A947-70E740481C1C}">
                 <a14:useLocalDpi xmlns:a14="http://schemas.microsoft.com/office/drawing/2010/main" val="0"/>
@@ -6670,8 +7359,8 @@
         </p:blipFill>
         <p:spPr bwMode="auto">
           <a:xfrm>
-            <a:off x="6555166" y="700217"/>
-            <a:ext cx="4401158" cy="5445690"/>
+            <a:off x="6427548" y="716690"/>
+            <a:ext cx="4701772" cy="5558035"/>
           </a:xfrm>
           <a:prstGeom prst="rect">
             <a:avLst/>
@@ -6684,37 +7373,30 @@
       </p:pic>
       <p:sp>
         <p:nvSpPr>
-          <p:cNvPr id="2" name="Прямокутник 1">
-            <a:extLst>
-              <a:ext uri="{FF2B5EF4-FFF2-40B4-BE49-F238E27FC236}">
-                <a16:creationId xmlns:a16="http://schemas.microsoft.com/office/drawing/2014/main" id="{20414F42-0A7C-4EE5-9D1D-B8A493FD4477}"/>
-              </a:ext>
-            </a:extLst>
-          </p:cNvPr>
-          <p:cNvSpPr/>
-          <p:nvPr/>
-        </p:nvSpPr>
-        <p:spPr>
-          <a:xfrm>
-            <a:off x="1265659" y="1969013"/>
-            <a:ext cx="4275438" cy="646331"/>
-          </a:xfrm>
-          <a:prstGeom prst="rect">
-            <a:avLst/>
-          </a:prstGeom>
-        </p:spPr>
-        <p:txBody>
-          <a:bodyPr wrap="square">
-            <a:spAutoFit/>
-          </a:bodyPr>
-          <a:lstStyle/>
-          <a:p>
-            <a:r>
-              <a:rPr lang="uk-UA" dirty="0">
-                <a:latin typeface="Arial" panose="020B0604020202020204" pitchFamily="34" charset="0"/>
-              </a:rPr>
-              <a:t>UML-діаграма класів для сутностей, які реалізовують процес гри</a:t>
-            </a:r>
+          <p:cNvPr id="3" name="Місце для номера слайда 2">
+            <a:extLst>
+              <a:ext uri="{FF2B5EF4-FFF2-40B4-BE49-F238E27FC236}">
+                <a16:creationId xmlns:a16="http://schemas.microsoft.com/office/drawing/2014/main" id="{B076368F-DE80-49BA-8DD8-876E0D890870}"/>
+              </a:ext>
+            </a:extLst>
+          </p:cNvPr>
+          <p:cNvSpPr>
+            <a:spLocks noGrp="1"/>
+          </p:cNvSpPr>
+          <p:nvPr>
+            <p:ph type="sldNum" sz="quarter" idx="12"/>
+          </p:nvPr>
+        </p:nvSpPr>
+        <p:spPr/>
+        <p:txBody>
+          <a:bodyPr/>
+          <a:lstStyle/>
+          <a:p>
+            <a:fld id="{4381394B-84A4-4EB2-8589-B7B2B99E12DD}" type="slidenum">
+              <a:rPr lang="uk-UA" smtClean="0"/>
+              <a:t>7</a:t>
+            </a:fld>
+            <a:endParaRPr lang="uk-UA"/>
           </a:p>
         </p:txBody>
       </p:sp>
@@ -6874,6 +7556,35 @@
           </a:ln>
         </p:spPr>
       </p:pic>
+      <p:sp>
+        <p:nvSpPr>
+          <p:cNvPr id="3" name="Місце для номера слайда 2">
+            <a:extLst>
+              <a:ext uri="{FF2B5EF4-FFF2-40B4-BE49-F238E27FC236}">
+                <a16:creationId xmlns:a16="http://schemas.microsoft.com/office/drawing/2014/main" id="{518D4E8F-D1A8-4009-A19F-B9A5F282F1FD}"/>
+              </a:ext>
+            </a:extLst>
+          </p:cNvPr>
+          <p:cNvSpPr>
+            <a:spLocks noGrp="1"/>
+          </p:cNvSpPr>
+          <p:nvPr>
+            <p:ph type="sldNum" sz="quarter" idx="12"/>
+          </p:nvPr>
+        </p:nvSpPr>
+        <p:spPr/>
+        <p:txBody>
+          <a:bodyPr/>
+          <a:lstStyle/>
+          <a:p>
+            <a:fld id="{4381394B-84A4-4EB2-8589-B7B2B99E12DD}" type="slidenum">
+              <a:rPr lang="uk-UA" smtClean="0"/>
+              <a:t>8</a:t>
+            </a:fld>
+            <a:endParaRPr lang="uk-UA"/>
+          </a:p>
+        </p:txBody>
+      </p:sp>
     </p:spTree>
     <p:extLst>
       <p:ext uri="{BB962C8B-B14F-4D97-AF65-F5344CB8AC3E}">
@@ -7169,6 +7880,35 @@
             <a:endParaRPr lang="en-US" dirty="0">
               <a:latin typeface="Arial" panose="020B0604020202020204" pitchFamily="34" charset="0"/>
             </a:endParaRPr>
+          </a:p>
+        </p:txBody>
+      </p:sp>
+      <p:sp>
+        <p:nvSpPr>
+          <p:cNvPr id="2" name="Місце для номера слайда 1">
+            <a:extLst>
+              <a:ext uri="{FF2B5EF4-FFF2-40B4-BE49-F238E27FC236}">
+                <a16:creationId xmlns:a16="http://schemas.microsoft.com/office/drawing/2014/main" id="{C939DB5B-3055-48F6-BD66-63546602A4B6}"/>
+              </a:ext>
+            </a:extLst>
+          </p:cNvPr>
+          <p:cNvSpPr>
+            <a:spLocks noGrp="1"/>
+          </p:cNvSpPr>
+          <p:nvPr>
+            <p:ph type="sldNum" sz="quarter" idx="12"/>
+          </p:nvPr>
+        </p:nvSpPr>
+        <p:spPr/>
+        <p:txBody>
+          <a:bodyPr/>
+          <a:lstStyle/>
+          <a:p>
+            <a:fld id="{4381394B-84A4-4EB2-8589-B7B2B99E12DD}" type="slidenum">
+              <a:rPr lang="uk-UA" smtClean="0"/>
+              <a:t>9</a:t>
+            </a:fld>
+            <a:endParaRPr lang="uk-UA"/>
           </a:p>
         </p:txBody>
       </p:sp>
@@ -7481,4 +8221,299 @@
     </a:ext>
   </a:extLst>
 </a:theme>
+</file>
+
+<file path=ppt/theme/theme2.xml><?xml version="1.0" encoding="utf-8"?>
+<a:theme xmlns:a="http://schemas.openxmlformats.org/drawingml/2006/main" name="Тема Office">
+  <a:themeElements>
+    <a:clrScheme name="Офіс">
+      <a:dk1>
+        <a:sysClr val="windowText" lastClr="000000"/>
+      </a:dk1>
+      <a:lt1>
+        <a:sysClr val="window" lastClr="FFFFFF"/>
+      </a:lt1>
+      <a:dk2>
+        <a:srgbClr val="44546A"/>
+      </a:dk2>
+      <a:lt2>
+        <a:srgbClr val="E7E6E6"/>
+      </a:lt2>
+      <a:accent1>
+        <a:srgbClr val="4472C4"/>
+      </a:accent1>
+      <a:accent2>
+        <a:srgbClr val="ED7D31"/>
+      </a:accent2>
+      <a:accent3>
+        <a:srgbClr val="A5A5A5"/>
+      </a:accent3>
+      <a:accent4>
+        <a:srgbClr val="FFC000"/>
+      </a:accent4>
+      <a:accent5>
+        <a:srgbClr val="5B9BD5"/>
+      </a:accent5>
+      <a:accent6>
+        <a:srgbClr val="70AD47"/>
+      </a:accent6>
+      <a:hlink>
+        <a:srgbClr val="0563C1"/>
+      </a:hlink>
+      <a:folHlink>
+        <a:srgbClr val="954F72"/>
+      </a:folHlink>
+    </a:clrScheme>
+    <a:fontScheme name="Офіс">
+      <a:majorFont>
+        <a:latin typeface="Calibri Light" panose="020F0302020204030204"/>
+        <a:ea typeface=""/>
+        <a:cs typeface=""/>
+        <a:font script="Jpan" typeface="游ゴシック Light"/>
+        <a:font script="Hang" typeface="맑은 고딕"/>
+        <a:font script="Hans" typeface="等线 Light"/>
+        <a:font script="Hant" typeface="新細明體"/>
+        <a:font script="Arab" typeface="Times New Roman"/>
+        <a:font script="Hebr" typeface="Times New Roman"/>
+        <a:font script="Thai" typeface="Angsana New"/>
+        <a:font script="Ethi" typeface="Nyala"/>
+        <a:font script="Beng" typeface="Vrinda"/>
+        <a:font script="Gujr" typeface="Shruti"/>
+        <a:font script="Khmr" typeface="MoolBoran"/>
+        <a:font script="Knda" typeface="Tunga"/>
+        <a:font script="Guru" typeface="Raavi"/>
+        <a:font script="Cans" typeface="Euphemia"/>
+        <a:font script="Cher" typeface="Plantagenet Cherokee"/>
+        <a:font script="Yiii" typeface="Microsoft Yi Baiti"/>
+        <a:font script="Tibt" typeface="Microsoft Himalaya"/>
+        <a:font script="Thaa" typeface="MV Boli"/>
+        <a:font script="Deva" typeface="Mangal"/>
+        <a:font script="Telu" typeface="Gautami"/>
+        <a:font script="Taml" typeface="Latha"/>
+        <a:font script="Syrc" typeface="Estrangelo Edessa"/>
+        <a:font script="Orya" typeface="Kalinga"/>
+        <a:font script="Mlym" typeface="Kartika"/>
+        <a:font script="Laoo" typeface="DokChampa"/>
+        <a:font script="Sinh" typeface="Iskoola Pota"/>
+        <a:font script="Mong" typeface="Mongolian Baiti"/>
+        <a:font script="Viet" typeface="Times New Roman"/>
+        <a:font script="Uigh" typeface="Microsoft Uighur"/>
+        <a:font script="Geor" typeface="Sylfaen"/>
+        <a:font script="Armn" typeface="Arial"/>
+        <a:font script="Bugi" typeface="Leelawadee UI"/>
+        <a:font script="Bopo" typeface="Microsoft JhengHei"/>
+        <a:font script="Java" typeface="Javanese Text"/>
+        <a:font script="Lisu" typeface="Segoe UI"/>
+        <a:font script="Mymr" typeface="Myanmar Text"/>
+        <a:font script="Nkoo" typeface="Ebrima"/>
+        <a:font script="Olck" typeface="Nirmala UI"/>
+        <a:font script="Osma" typeface="Ebrima"/>
+        <a:font script="Phag" typeface="Phagspa"/>
+        <a:font script="Syrn" typeface="Estrangelo Edessa"/>
+        <a:font script="Syrj" typeface="Estrangelo Edessa"/>
+        <a:font script="Syre" typeface="Estrangelo Edessa"/>
+        <a:font script="Sora" typeface="Nirmala UI"/>
+        <a:font script="Tale" typeface="Microsoft Tai Le"/>
+        <a:font script="Talu" typeface="Microsoft New Tai Lue"/>
+        <a:font script="Tfng" typeface="Ebrima"/>
+      </a:majorFont>
+      <a:minorFont>
+        <a:latin typeface="Calibri" panose="020F0502020204030204"/>
+        <a:ea typeface=""/>
+        <a:cs typeface=""/>
+        <a:font script="Jpan" typeface="游ゴシック"/>
+        <a:font script="Hang" typeface="맑은 고딕"/>
+        <a:font script="Hans" typeface="等线"/>
+        <a:font script="Hant" typeface="新細明體"/>
+        <a:font script="Arab" typeface="Arial"/>
+        <a:font script="Hebr" typeface="Arial"/>
+        <a:font script="Thai" typeface="Cordia New"/>
+        <a:font script="Ethi" typeface="Nyala"/>
+        <a:font script="Beng" typeface="Vrinda"/>
+        <a:font script="Gujr" typeface="Shruti"/>
+        <a:font script="Khmr" typeface="DaunPenh"/>
+        <a:font script="Knda" typeface="Tunga"/>
+        <a:font script="Guru" typeface="Raavi"/>
+        <a:font script="Cans" typeface="Euphemia"/>
+        <a:font script="Cher" typeface="Plantagenet Cherokee"/>
+        <a:font script="Yiii" typeface="Microsoft Yi Baiti"/>
+        <a:font script="Tibt" typeface="Microsoft Himalaya"/>
+        <a:font script="Thaa" typeface="MV Boli"/>
+        <a:font script="Deva" typeface="Mangal"/>
+        <a:font script="Telu" typeface="Gautami"/>
+        <a:font script="Taml" typeface="Latha"/>
+        <a:font script="Syrc" typeface="Estrangelo Edessa"/>
+        <a:font script="Orya" typeface="Kalinga"/>
+        <a:font script="Mlym" typeface="Kartika"/>
+        <a:font script="Laoo" typeface="DokChampa"/>
+        <a:font script="Sinh" typeface="Iskoola Pota"/>
+        <a:font script="Mong" typeface="Mongolian Baiti"/>
+        <a:font script="Viet" typeface="Arial"/>
+        <a:font script="Uigh" typeface="Microsoft Uighur"/>
+        <a:font script="Geor" typeface="Sylfaen"/>
+        <a:font script="Armn" typeface="Arial"/>
+        <a:font script="Bugi" typeface="Leelawadee UI"/>
+        <a:font script="Bopo" typeface="Microsoft JhengHei"/>
+        <a:font script="Java" typeface="Javanese Text"/>
+        <a:font script="Lisu" typeface="Segoe UI"/>
+        <a:font script="Mymr" typeface="Myanmar Text"/>
+        <a:font script="Nkoo" typeface="Ebrima"/>
+        <a:font script="Olck" typeface="Nirmala UI"/>
+        <a:font script="Osma" typeface="Ebrima"/>
+        <a:font script="Phag" typeface="Phagspa"/>
+        <a:font script="Syrn" typeface="Estrangelo Edessa"/>
+        <a:font script="Syrj" typeface="Estrangelo Edessa"/>
+        <a:font script="Syre" typeface="Estrangelo Edessa"/>
+        <a:font script="Sora" typeface="Nirmala UI"/>
+        <a:font script="Tale" typeface="Microsoft Tai Le"/>
+        <a:font script="Talu" typeface="Microsoft New Tai Lue"/>
+        <a:font script="Tfng" typeface="Ebrima"/>
+      </a:minorFont>
+    </a:fontScheme>
+    <a:fmtScheme name="Офіс">
+      <a:fillStyleLst>
+        <a:solidFill>
+          <a:schemeClr val="phClr"/>
+        </a:solidFill>
+        <a:gradFill rotWithShape="1">
+          <a:gsLst>
+            <a:gs pos="0">
+              <a:schemeClr val="phClr">
+                <a:lumMod val="110000"/>
+                <a:satMod val="105000"/>
+                <a:tint val="67000"/>
+              </a:schemeClr>
+            </a:gs>
+            <a:gs pos="50000">
+              <a:schemeClr val="phClr">
+                <a:lumMod val="105000"/>
+                <a:satMod val="103000"/>
+                <a:tint val="73000"/>
+              </a:schemeClr>
+            </a:gs>
+            <a:gs pos="100000">
+              <a:schemeClr val="phClr">
+                <a:lumMod val="105000"/>
+                <a:satMod val="109000"/>
+                <a:tint val="81000"/>
+              </a:schemeClr>
+            </a:gs>
+          </a:gsLst>
+          <a:lin ang="5400000" scaled="0"/>
+        </a:gradFill>
+        <a:gradFill rotWithShape="1">
+          <a:gsLst>
+            <a:gs pos="0">
+              <a:schemeClr val="phClr">
+                <a:satMod val="103000"/>
+                <a:lumMod val="102000"/>
+                <a:tint val="94000"/>
+              </a:schemeClr>
+            </a:gs>
+            <a:gs pos="50000">
+              <a:schemeClr val="phClr">
+                <a:satMod val="110000"/>
+                <a:lumMod val="100000"/>
+                <a:shade val="100000"/>
+              </a:schemeClr>
+            </a:gs>
+            <a:gs pos="100000">
+              <a:schemeClr val="phClr">
+                <a:lumMod val="99000"/>
+                <a:satMod val="120000"/>
+                <a:shade val="78000"/>
+              </a:schemeClr>
+            </a:gs>
+          </a:gsLst>
+          <a:lin ang="5400000" scaled="0"/>
+        </a:gradFill>
+      </a:fillStyleLst>
+      <a:lnStyleLst>
+        <a:ln w="6350" cap="flat" cmpd="sng" algn="ctr">
+          <a:solidFill>
+            <a:schemeClr val="phClr"/>
+          </a:solidFill>
+          <a:prstDash val="solid"/>
+          <a:miter lim="800000"/>
+        </a:ln>
+        <a:ln w="12700" cap="flat" cmpd="sng" algn="ctr">
+          <a:solidFill>
+            <a:schemeClr val="phClr"/>
+          </a:solidFill>
+          <a:prstDash val="solid"/>
+          <a:miter lim="800000"/>
+        </a:ln>
+        <a:ln w="19050" cap="flat" cmpd="sng" algn="ctr">
+          <a:solidFill>
+            <a:schemeClr val="phClr"/>
+          </a:solidFill>
+          <a:prstDash val="solid"/>
+          <a:miter lim="800000"/>
+        </a:ln>
+      </a:lnStyleLst>
+      <a:effectStyleLst>
+        <a:effectStyle>
+          <a:effectLst/>
+        </a:effectStyle>
+        <a:effectStyle>
+          <a:effectLst/>
+        </a:effectStyle>
+        <a:effectStyle>
+          <a:effectLst>
+            <a:outerShdw blurRad="57150" dist="19050" dir="5400000" algn="ctr" rotWithShape="0">
+              <a:srgbClr val="000000">
+                <a:alpha val="63000"/>
+              </a:srgbClr>
+            </a:outerShdw>
+          </a:effectLst>
+        </a:effectStyle>
+      </a:effectStyleLst>
+      <a:bgFillStyleLst>
+        <a:solidFill>
+          <a:schemeClr val="phClr"/>
+        </a:solidFill>
+        <a:solidFill>
+          <a:schemeClr val="phClr">
+            <a:tint val="95000"/>
+            <a:satMod val="170000"/>
+          </a:schemeClr>
+        </a:solidFill>
+        <a:gradFill rotWithShape="1">
+          <a:gsLst>
+            <a:gs pos="0">
+              <a:schemeClr val="phClr">
+                <a:tint val="93000"/>
+                <a:satMod val="150000"/>
+                <a:shade val="98000"/>
+                <a:lumMod val="102000"/>
+              </a:schemeClr>
+            </a:gs>
+            <a:gs pos="50000">
+              <a:schemeClr val="phClr">
+                <a:tint val="98000"/>
+                <a:satMod val="130000"/>
+                <a:shade val="90000"/>
+                <a:lumMod val="103000"/>
+              </a:schemeClr>
+            </a:gs>
+            <a:gs pos="100000">
+              <a:schemeClr val="phClr">
+                <a:shade val="63000"/>
+                <a:satMod val="120000"/>
+              </a:schemeClr>
+            </a:gs>
+          </a:gsLst>
+          <a:lin ang="5400000" scaled="0"/>
+        </a:gradFill>
+      </a:bgFillStyleLst>
+    </a:fmtScheme>
+  </a:themeElements>
+  <a:objectDefaults/>
+  <a:extraClrSchemeLst/>
+  <a:extLst>
+    <a:ext uri="{05A4C25C-085E-4340-85A3-A5531E510DB2}">
+      <thm15:themeFamily xmlns:thm15="http://schemas.microsoft.com/office/thememl/2012/main" name="Office Theme" id="{62F939B6-93AF-4DB8-9C6B-D6C7DFDC589F}" vid="{4A3C46E8-61CC-4603-A589-7422A47A8E4A}"/>
+    </a:ext>
+  </a:extLst>
+</a:theme>
 </file>
</xml_diff>